<commit_message>
first expo project created
</commit_message>
<xml_diff>
--- a/lab1/lab1.pptx
+++ b/lab1/lab1.pptx
@@ -3571,7 +3571,7 @@
           <a:p>
             <a:r>
               <a:rPr lang="en-US" dirty="0"/>
-              <a:t>Prototype Development</a:t>
+              <a:t>Prototype Development Idea?</a:t>
             </a:r>
           </a:p>
         </p:txBody>
@@ -3616,10 +3616,9 @@
           </a:p>
           <a:p>
             <a:r>
-              <a:rPr lang="en-US"/>
-              <a:t>etc</a:t>
-            </a:r>
-            <a:endParaRPr lang="en-US" dirty="0"/>
+              <a:rPr lang="en-US" dirty="0"/>
+              <a:t>Etc.</a:t>
+            </a:r>
           </a:p>
         </p:txBody>
       </p:sp>

</xml_diff>